<commit_message>
Expert Elite vitrini + kapakta kurucu adı + slayt-içi animasyon tekrarı
- field.js: animasyonlar artık her slayt görünür olduğunda (IntersectionObserver)
  yeniden oynuyor — deck'te kaydırdıkça her kare kendi çözünürlük animasyonunu gösteriyor
- Kapak (PPTX + HTML + md): Enes Cemil Yağcı · Founder & BIM Manager eklendi,
  pirinç renkli 'Autodesk Expert Elite — ~250 worldwide' satırı eklendi
- Slide 5 (PPTX + HTML + md): pirinç çerçeveli Expert Elite paneli (~250 büyük punto)
- Capability statement (HTML + md) ve e-posta şablonları Expert Elite vurgusuyla güncellendi
</commit_message>
<xml_diff>
--- a/uk-market-expansion/pptx/ECY-UK-Pitch-Deck.pptx
+++ b/uk-market-expansion/pptx/ECY-UK-Pitch-Deck.pptx
@@ -3351,6 +3351,45 @@
         </p:nvSpPr>
         <p:spPr>
           <a:xfrm>
+            <a:off x="841248" y="5349240"/>
+            <a:ext cx="9601200" cy="365760"/>
+          </a:xfrm>
+          <a:prstGeom prst="rect">
+            <a:avLst/>
+          </a:prstGeom>
+          <a:noFill/>
+        </p:spPr>
+        <p:txBody>
+          <a:bodyPr wrap="square" anchor="t" lIns="0" rIns="0" tIns="0" bIns="0">
+            <a:spAutoFit/>
+          </a:bodyPr>
+          <a:lstStyle/>
+          <a:p>
+            <a:pPr algn="l">
+              <a:lnSpc>
+                <a:spcPct val="100000"/>
+              </a:lnSpc>
+            </a:pPr>
+            <a:r>
+              <a:rPr sz="950" b="0" i="0">
+                <a:solidFill>
+                  <a:srgbClr val="BD9457"/>
+                </a:solidFill>
+                <a:latin typeface="Consolas"/>
+              </a:rPr>
+              <a:t>FOUNDED BY AN AUTODESK EXPERT ELITE · A RECOGNITION HELD BY ONLY ~250 PROFESSIONALS WORLDWIDE</a:t>
+            </a:r>
+          </a:p>
+        </p:txBody>
+      </p:sp>
+      <p:sp>
+        <p:nvSpPr>
+          <p:cNvPr id="9" name="TextBox 8"/>
+          <p:cNvSpPr txBox="1"/>
+          <p:nvPr/>
+        </p:nvSpPr>
+        <p:spPr>
+          <a:xfrm>
             <a:off x="841248" y="5989320"/>
             <a:ext cx="10515600" cy="365760"/>
           </a:xfrm>
@@ -3377,7 +3416,7 @@
                 </a:solidFill>
                 <a:latin typeface="Consolas"/>
               </a:rPr>
-              <a:t>Rami Daşkın · UK Representative · +44 7786 410586        </a:t>
+              <a:t>Enes Cemil Yağcı · Founder &amp; BIM Manager    ·    Rami Daşkın · UK Representative · +44 7786 410586        </a:t>
             </a:r>
             <a:r>
               <a:rPr sz="950" b="0" i="0">
@@ -6191,8 +6230,8 @@
         </p:nvSpPr>
         <p:spPr>
           <a:xfrm>
-            <a:off x="841248" y="2468880"/>
-            <a:ext cx="5120640" cy="1645920"/>
+            <a:off x="841248" y="1737360"/>
+            <a:ext cx="5120640" cy="1463040"/>
           </a:xfrm>
           <a:prstGeom prst="rect">
             <a:avLst/>
@@ -6261,7 +6300,139 @@
       </p:sp>
       <p:sp>
         <p:nvSpPr>
-          <p:cNvPr id="6" name="TextBox 5"/>
+          <p:cNvPr id="6" name="Rectangle 5"/>
+          <p:cNvSpPr/>
+          <p:nvPr/>
+        </p:nvSpPr>
+        <p:spPr>
+          <a:xfrm>
+            <a:off x="841248" y="3794760"/>
+            <a:ext cx="5120640" cy="2240280"/>
+          </a:xfrm>
+          <a:prstGeom prst="rect">
+            <a:avLst/>
+          </a:prstGeom>
+          <a:solidFill>
+            <a:srgbClr val="241C13"/>
+          </a:solidFill>
+          <a:ln w="19050">
+            <a:solidFill>
+              <a:srgbClr val="BD9457"/>
+            </a:solidFill>
+          </a:ln>
+          <a:effectLst/>
+        </p:spPr>
+        <p:style>
+          <a:lnRef idx="1">
+            <a:schemeClr val="accent1"/>
+          </a:lnRef>
+          <a:fillRef idx="3">
+            <a:schemeClr val="accent1"/>
+          </a:fillRef>
+          <a:effectRef idx="2">
+            <a:schemeClr val="accent1"/>
+          </a:effectRef>
+          <a:fontRef idx="minor">
+            <a:schemeClr val="lt1"/>
+          </a:fontRef>
+        </p:style>
+        <p:txBody>
+          <a:bodyPr rtlCol="0" anchor="ctr"/>
+          <a:lstStyle/>
+          <a:p>
+            <a:pPr algn="ctr"/>
+          </a:p>
+        </p:txBody>
+      </p:sp>
+      <p:sp>
+        <p:nvSpPr>
+          <p:cNvPr id="7" name="TextBox 6"/>
+          <p:cNvSpPr txBox="1"/>
+          <p:nvPr/>
+        </p:nvSpPr>
+        <p:spPr>
+          <a:xfrm>
+            <a:off x="1097280" y="4023360"/>
+            <a:ext cx="4663440" cy="1828800"/>
+          </a:xfrm>
+          <a:prstGeom prst="rect">
+            <a:avLst/>
+          </a:prstGeom>
+          <a:noFill/>
+        </p:spPr>
+        <p:txBody>
+          <a:bodyPr wrap="square" anchor="t" lIns="0" rIns="0" tIns="0" bIns="0">
+            <a:spAutoFit/>
+          </a:bodyPr>
+          <a:lstStyle/>
+          <a:p>
+            <a:pPr algn="l">
+              <a:lnSpc>
+                <a:spcPct val="100000"/>
+              </a:lnSpc>
+              <a:spcAft>
+                <a:spcPts val="600"/>
+              </a:spcAft>
+            </a:pPr>
+            <a:r>
+              <a:rPr sz="1000" b="0" i="0">
+                <a:solidFill>
+                  <a:srgbClr val="BD9457"/>
+                </a:solidFill>
+                <a:latin typeface="Consolas"/>
+              </a:rPr>
+              <a:t>AUTODESK EXPERT ELITE</a:t>
+            </a:r>
+          </a:p>
+          <a:p>
+            <a:pPr algn="l">
+              <a:lnSpc>
+                <a:spcPct val="100000"/>
+              </a:lnSpc>
+              <a:spcAft>
+                <a:spcPts val="600"/>
+              </a:spcAft>
+            </a:pPr>
+            <a:r>
+              <a:rPr sz="3400" b="0" i="0">
+                <a:solidFill>
+                  <a:srgbClr val="DBB571"/>
+                </a:solidFill>
+                <a:latin typeface="Segoe UI Light"/>
+              </a:rPr>
+              <a:t>~250 </a:t>
+            </a:r>
+            <a:r>
+              <a:rPr sz="1300" b="0" i="0">
+                <a:solidFill>
+                  <a:srgbClr val="B9AE99"/>
+                </a:solidFill>
+                <a:latin typeface="Segoe UI Light"/>
+              </a:rPr>
+              <a:t>hold this worldwide</a:t>
+            </a:r>
+          </a:p>
+          <a:p>
+            <a:pPr algn="l">
+              <a:lnSpc>
+                <a:spcPct val="130000"/>
+              </a:lnSpc>
+            </a:pPr>
+            <a:r>
+              <a:rPr sz="1150" b="0" i="0">
+                <a:solidFill>
+                  <a:srgbClr val="877C6B"/>
+                </a:solidFill>
+                <a:latin typeface="Segoe UI Light"/>
+              </a:rPr>
+              <a:t>Our founder, Enes Cemil Yağcı, is one of them — Autodesk's global recognition of verified expertise and community contribution.</a:t>
+            </a:r>
+          </a:p>
+        </p:txBody>
+      </p:sp>
+      <p:sp>
+        <p:nvSpPr>
+          <p:cNvPr id="8" name="TextBox 7"/>
           <p:cNvSpPr txBox="1"/>
           <p:nvPr/>
         </p:nvSpPr>
@@ -6309,7 +6480,7 @@
       </p:sp>
       <p:sp>
         <p:nvSpPr>
-          <p:cNvPr id="7" name="TextBox 6"/>
+          <p:cNvPr id="9" name="TextBox 8"/>
           <p:cNvSpPr txBox="1"/>
           <p:nvPr/>
         </p:nvSpPr>
@@ -6348,7 +6519,7 @@
       </p:sp>
       <p:sp>
         <p:nvSpPr>
-          <p:cNvPr id="8" name="TextBox 7"/>
+          <p:cNvPr id="10" name="TextBox 9"/>
           <p:cNvSpPr txBox="1"/>
           <p:nvPr/>
         </p:nvSpPr>
@@ -6385,18 +6556,18 @@
             <a:r>
               <a:rPr sz="1450" b="0" i="0">
                 <a:solidFill>
-                  <a:srgbClr val="ECE3D1"/>
+                  <a:srgbClr val="DBB571"/>
                 </a:solidFill>
                 <a:latin typeface="Segoe UI"/>
               </a:rPr>
-              <a:t>Autodesk Expert Elite · openBIM · P6</a:t>
-            </a:r>
-          </a:p>
-        </p:txBody>
-      </p:sp>
-      <p:sp>
-        <p:nvSpPr>
-          <p:cNvPr id="9" name="TextBox 8"/>
+              <a:t>Autodesk Expert Elite founder · ~250 worldwide</a:t>
+            </a:r>
+          </a:p>
+        </p:txBody>
+      </p:sp>
+      <p:sp>
+        <p:nvSpPr>
+          <p:cNvPr id="11" name="TextBox 10"/>
           <p:cNvSpPr txBox="1"/>
           <p:nvPr/>
         </p:nvSpPr>
@@ -6428,14 +6599,14 @@
                 </a:solidFill>
                 <a:latin typeface="Consolas"/>
               </a:rPr>
-              <a:t>CERTIFIED</a:t>
-            </a:r>
-          </a:p>
-        </p:txBody>
-      </p:sp>
-      <p:sp>
-        <p:nvSpPr>
-          <p:cNvPr id="10" name="TextBox 9"/>
+              <a:t>ELITE</a:t>
+            </a:r>
+          </a:p>
+        </p:txBody>
+      </p:sp>
+      <p:sp>
+        <p:nvSpPr>
+          <p:cNvPr id="12" name="TextBox 11"/>
           <p:cNvSpPr txBox="1"/>
           <p:nvPr/>
         </p:nvSpPr>
@@ -6476,14 +6647,14 @@
                 </a:solidFill>
                 <a:latin typeface="Segoe UI"/>
               </a:rPr>
-              <a:t>Delivery across 17 countries</a:t>
-            </a:r>
-          </a:p>
-        </p:txBody>
-      </p:sp>
-      <p:sp>
-        <p:nvSpPr>
-          <p:cNvPr id="11" name="TextBox 10"/>
+              <a:t>openBIM Foundation · Primavera P6 certified</a:t>
+            </a:r>
+          </a:p>
+        </p:txBody>
+      </p:sp>
+      <p:sp>
+        <p:nvSpPr>
+          <p:cNvPr id="13" name="TextBox 12"/>
           <p:cNvSpPr txBox="1"/>
           <p:nvPr/>
         </p:nvSpPr>
@@ -6515,14 +6686,14 @@
                 </a:solidFill>
                 <a:latin typeface="Consolas"/>
               </a:rPr>
-              <a:t>PROVEN</a:t>
-            </a:r>
-          </a:p>
-        </p:txBody>
-      </p:sp>
-      <p:sp>
-        <p:nvSpPr>
-          <p:cNvPr id="12" name="TextBox 11"/>
+              <a:t>CERTIFIED</a:t>
+            </a:r>
+          </a:p>
+        </p:txBody>
+      </p:sp>
+      <p:sp>
+        <p:nvSpPr>
+          <p:cNvPr id="14" name="TextBox 13"/>
           <p:cNvSpPr txBox="1"/>
           <p:nvPr/>
         </p:nvSpPr>
@@ -6563,6 +6734,93 @@
                 </a:solidFill>
                 <a:latin typeface="Segoe UI"/>
               </a:rPr>
+              <a:t>Delivery across 17 countries</a:t>
+            </a:r>
+          </a:p>
+        </p:txBody>
+      </p:sp>
+      <p:sp>
+        <p:nvSpPr>
+          <p:cNvPr id="15" name="TextBox 14"/>
+          <p:cNvSpPr txBox="1"/>
+          <p:nvPr/>
+        </p:nvSpPr>
+        <p:spPr>
+          <a:xfrm>
+            <a:off x="9795967" y="4379976"/>
+            <a:ext cx="1554480" cy="365760"/>
+          </a:xfrm>
+          <a:prstGeom prst="rect">
+            <a:avLst/>
+          </a:prstGeom>
+          <a:noFill/>
+        </p:spPr>
+        <p:txBody>
+          <a:bodyPr wrap="square" anchor="t" lIns="0" rIns="0" tIns="0" bIns="0">
+            <a:spAutoFit/>
+          </a:bodyPr>
+          <a:lstStyle/>
+          <a:p>
+            <a:pPr algn="r">
+              <a:lnSpc>
+                <a:spcPct val="100000"/>
+              </a:lnSpc>
+            </a:pPr>
+            <a:r>
+              <a:rPr sz="850" b="0" i="0">
+                <a:solidFill>
+                  <a:srgbClr val="6E6657"/>
+                </a:solidFill>
+                <a:latin typeface="Consolas"/>
+              </a:rPr>
+              <a:t>PROVEN</a:t>
+            </a:r>
+          </a:p>
+        </p:txBody>
+      </p:sp>
+      <p:sp>
+        <p:nvSpPr>
+          <p:cNvPr id="16" name="TextBox 15"/>
+          <p:cNvSpPr txBox="1"/>
+          <p:nvPr/>
+        </p:nvSpPr>
+        <p:spPr>
+          <a:xfrm>
+            <a:off x="6766560" y="5010912"/>
+            <a:ext cx="4572000" cy="457200"/>
+          </a:xfrm>
+          <a:prstGeom prst="rect">
+            <a:avLst/>
+          </a:prstGeom>
+          <a:noFill/>
+        </p:spPr>
+        <p:txBody>
+          <a:bodyPr wrap="square" anchor="t" lIns="0" rIns="0" tIns="0" bIns="0">
+            <a:spAutoFit/>
+          </a:bodyPr>
+          <a:lstStyle/>
+          <a:p>
+            <a:pPr algn="l">
+              <a:lnSpc>
+                <a:spcPct val="100000"/>
+              </a:lnSpc>
+            </a:pPr>
+            <a:r>
+              <a:rPr sz="1300" b="0" i="0">
+                <a:solidFill>
+                  <a:srgbClr val="BD9457"/>
+                </a:solidFill>
+                <a:latin typeface="Consolas"/>
+              </a:rPr>
+              <a:t>·  </a:t>
+            </a:r>
+            <a:r>
+              <a:rPr sz="1450" b="0" i="0">
+                <a:solidFill>
+                  <a:srgbClr val="ECE3D1"/>
+                </a:solidFill>
+                <a:latin typeface="Segoe UI"/>
+              </a:rPr>
               <a:t>Competitive rates, kept quality</a:t>
             </a:r>
           </a:p>
@@ -6570,13 +6828,13 @@
       </p:sp>
       <p:sp>
         <p:nvSpPr>
-          <p:cNvPr id="13" name="TextBox 12"/>
-          <p:cNvSpPr txBox="1"/>
-          <p:nvPr/>
-        </p:nvSpPr>
-        <p:spPr>
-          <a:xfrm>
-            <a:off x="9795967" y="4379976"/>
+          <p:cNvPr id="17" name="TextBox 16"/>
+          <p:cNvSpPr txBox="1"/>
+          <p:nvPr/>
+        </p:nvSpPr>
+        <p:spPr>
+          <a:xfrm>
+            <a:off x="9795967" y="5038344"/>
             <a:ext cx="1554480" cy="365760"/>
           </a:xfrm>
           <a:prstGeom prst="rect">

</xml_diff>

<commit_message>
Gerçek proje görselleri slaytlara gömüldü + Leas künyesi
- Slide 6: Erbil Hospital render'ı sağ panelde
- Slide 7: gerçek Scan-to-BIM before/after — kayıtlı nokta bulutu (HEMA_012)
  üstte, as-built Revit modeli (HEMA_01) altta; prosedürel split yerine gerçek kanıt
- Slide 8: Leas-1 görseli + künye (Grade II 1902, 91 daire, 133.715 sqft,
  RIBA Stage 5-7) — önceki işveren adı geçmiyor
- HTML deck (6/7/8) ve pitch-deck.md aynı içerikle senkronize
</commit_message>
<xml_diff>
--- a/uk-market-expansion/pptx/ECY-UK-Pitch-Deck.pptx
+++ b/uk-market-expansion/pptx/ECY-UK-Pitch-Deck.pptx
@@ -6985,12 +6985,20 @@
           </a:p>
         </p:txBody>
       </p:sp>
-      <p:sp>
-        <p:nvSpPr>
-          <p:cNvPr id="5" name="Rectangle 4"/>
-          <p:cNvSpPr/>
-          <p:nvPr/>
-        </p:nvSpPr>
+      <p:pic>
+        <p:nvPicPr>
+          <p:cNvPr id="5" name="Picture 4" descr="proj_erbil.jpg"/>
+          <p:cNvPicPr>
+            <a:picLocks noChangeAspect="1"/>
+          </p:cNvPicPr>
+          <p:nvPr/>
+        </p:nvPicPr>
+        <p:blipFill>
+          <a:blip r:embed="rId3"/>
+          <a:stretch>
+            <a:fillRect/>
+          </a:stretch>
+        </p:blipFill>
         <p:spPr>
           <a:xfrm>
             <a:off x="6126480" y="1371600"/>
@@ -6999,47 +7007,13 @@
           <a:prstGeom prst="rect">
             <a:avLst/>
           </a:prstGeom>
-          <a:solidFill>
-            <a:srgbClr val="201912"/>
-          </a:solidFill>
           <a:ln w="12700">
             <a:solidFill>
-              <a:srgbClr val="BD9457"/>
+              <a:srgbClr val="2A2114"/>
             </a:solidFill>
           </a:ln>
         </p:spPr>
-        <p:style>
-          <a:lnRef idx="1">
-            <a:schemeClr val="accent1"/>
-          </a:lnRef>
-          <a:fillRef idx="3">
-            <a:schemeClr val="accent1"/>
-          </a:fillRef>
-          <a:effectRef idx="2">
-            <a:schemeClr val="accent1"/>
-          </a:effectRef>
-          <a:fontRef idx="minor">
-            <a:schemeClr val="lt1"/>
-          </a:fontRef>
-        </p:style>
-        <p:txBody>
-          <a:bodyPr rtlCol="0" anchor="ctr" wrap="square"/>
-          <a:lstStyle/>
-          <a:p>
-            <a:pPr algn="ctr"/>
-            <a:r>
-              <a:rPr sz="1100">
-                <a:solidFill>
-                  <a:srgbClr val="877C6B"/>
-                </a:solidFill>
-                <a:latin typeface="Consolas"/>
-              </a:rPr>
-              <a:t>PROJECT IMAGE
-→ push to  pptx/projects/erbil/</a:t>
-            </a:r>
-          </a:p>
-        </p:txBody>
-      </p:sp>
+      </p:pic>
       <p:sp>
         <p:nvSpPr>
           <p:cNvPr id="6" name="TextBox 5"/>
@@ -7342,7 +7316,7 @@
       <p:grpSpPr/>
       <p:pic>
         <p:nvPicPr>
-          <p:cNvPr id="2" name="Picture 1" descr="split07.png"/>
+          <p:cNvPr id="2" name="Picture 1" descr="s07.png"/>
           <p:cNvPicPr>
             <a:picLocks noChangeAspect="1"/>
           </p:cNvPicPr>
@@ -7450,8 +7424,8 @@
         </p:nvSpPr>
         <p:spPr>
           <a:xfrm>
-            <a:off x="841248" y="1417320"/>
-            <a:ext cx="2743200" cy="365760"/>
+            <a:off x="5486400" y="1188720"/>
+            <a:ext cx="4572000" cy="274320"/>
           </a:xfrm>
           <a:prstGeom prst="rect">
             <a:avLst/>
@@ -7476,21 +7450,50 @@
                 </a:solidFill>
                 <a:latin typeface="Consolas"/>
               </a:rPr>
-              <a:t>BEFORE · POINT CLOUD</a:t>
-            </a:r>
-          </a:p>
-        </p:txBody>
-      </p:sp>
-      <p:sp>
-        <p:nvSpPr>
-          <p:cNvPr id="6" name="TextBox 5"/>
-          <p:cNvSpPr txBox="1"/>
-          <p:nvPr/>
-        </p:nvSpPr>
-        <p:spPr>
-          <a:xfrm>
-            <a:off x="6858000" y="1417320"/>
-            <a:ext cx="4572000" cy="365760"/>
+              <a:t>BEFORE · REGISTERED POINT CLOUD</a:t>
+            </a:r>
+          </a:p>
+        </p:txBody>
+      </p:sp>
+      <p:pic>
+        <p:nvPicPr>
+          <p:cNvPr id="6" name="Picture 5" descr="HEMA_012_fit.jpg"/>
+          <p:cNvPicPr>
+            <a:picLocks noChangeAspect="1"/>
+          </p:cNvPicPr>
+          <p:nvPr/>
+        </p:nvPicPr>
+        <p:blipFill>
+          <a:blip r:embed="rId3"/>
+          <a:stretch>
+            <a:fillRect/>
+          </a:stretch>
+        </p:blipFill>
+        <p:spPr>
+          <a:xfrm>
+            <a:off x="5486400" y="1481328"/>
+            <a:ext cx="5852160" cy="2103120"/>
+          </a:xfrm>
+          <a:prstGeom prst="rect">
+            <a:avLst/>
+          </a:prstGeom>
+          <a:ln w="12700">
+            <a:solidFill>
+              <a:srgbClr val="2A2114"/>
+            </a:solidFill>
+          </a:ln>
+        </p:spPr>
+      </p:pic>
+      <p:sp>
+        <p:nvSpPr>
+          <p:cNvPr id="7" name="TextBox 6"/>
+          <p:cNvSpPr txBox="1"/>
+          <p:nvPr/>
+        </p:nvSpPr>
+        <p:spPr>
+          <a:xfrm>
+            <a:off x="5486400" y="3767328"/>
+            <a:ext cx="4572000" cy="274320"/>
           </a:xfrm>
           <a:prstGeom prst="rect">
             <a:avLst/>
@@ -7515,40 +7518,69 @@
                 </a:solidFill>
                 <a:latin typeface="Consolas"/>
               </a:rPr>
-              <a:t>AFTER · BIM MODEL</a:t>
-            </a:r>
-          </a:p>
-        </p:txBody>
-      </p:sp>
-      <p:sp>
-        <p:nvSpPr>
-          <p:cNvPr id="7" name="TextBox 6"/>
-          <p:cNvSpPr txBox="1"/>
-          <p:nvPr/>
-        </p:nvSpPr>
-        <p:spPr>
-          <a:xfrm>
-            <a:off x="841248" y="4023360"/>
-            <a:ext cx="5669280" cy="365760"/>
-          </a:xfrm>
-          <a:prstGeom prst="rect">
-            <a:avLst/>
-          </a:prstGeom>
-          <a:noFill/>
-        </p:spPr>
-        <p:txBody>
-          <a:bodyPr wrap="square" anchor="t" lIns="0" rIns="0" tIns="0" bIns="0">
-            <a:spAutoFit/>
-          </a:bodyPr>
-          <a:lstStyle/>
-          <a:p>
-            <a:pPr algn="l">
-              <a:lnSpc>
-                <a:spcPct val="100000"/>
-              </a:lnSpc>
-            </a:pPr>
-            <a:r>
-              <a:rPr sz="1050" b="0" i="0">
+              <a:t>AFTER · AS-BUILT REVIT MODEL</a:t>
+            </a:r>
+          </a:p>
+        </p:txBody>
+      </p:sp>
+      <p:pic>
+        <p:nvPicPr>
+          <p:cNvPr id="8" name="Picture 7" descr="HEMA_01_fit.jpg"/>
+          <p:cNvPicPr>
+            <a:picLocks noChangeAspect="1"/>
+          </p:cNvPicPr>
+          <p:nvPr/>
+        </p:nvPicPr>
+        <p:blipFill>
+          <a:blip r:embed="rId4"/>
+          <a:stretch>
+            <a:fillRect/>
+          </a:stretch>
+        </p:blipFill>
+        <p:spPr>
+          <a:xfrm>
+            <a:off x="5486400" y="4059936"/>
+            <a:ext cx="5852160" cy="2103120"/>
+          </a:xfrm>
+          <a:prstGeom prst="rect">
+            <a:avLst/>
+          </a:prstGeom>
+          <a:ln w="12700">
+            <a:solidFill>
+              <a:srgbClr val="2A2114"/>
+            </a:solidFill>
+          </a:ln>
+        </p:spPr>
+      </p:pic>
+      <p:sp>
+        <p:nvSpPr>
+          <p:cNvPr id="9" name="TextBox 8"/>
+          <p:cNvSpPr txBox="1"/>
+          <p:nvPr/>
+        </p:nvSpPr>
+        <p:spPr>
+          <a:xfrm>
+            <a:off x="841248" y="1481328"/>
+            <a:ext cx="4297680" cy="365760"/>
+          </a:xfrm>
+          <a:prstGeom prst="rect">
+            <a:avLst/>
+          </a:prstGeom>
+          <a:noFill/>
+        </p:spPr>
+        <p:txBody>
+          <a:bodyPr wrap="square" anchor="t" lIns="0" rIns="0" tIns="0" bIns="0">
+            <a:spAutoFit/>
+          </a:bodyPr>
+          <a:lstStyle/>
+          <a:p>
+            <a:pPr algn="l">
+              <a:lnSpc>
+                <a:spcPct val="100000"/>
+              </a:lnSpc>
+            </a:pPr>
+            <a:r>
+              <a:rPr sz="1000" b="0" i="0">
                 <a:solidFill>
                   <a:srgbClr val="BD9457"/>
                 </a:solidFill>
@@ -7561,14 +7593,14 @@
       </p:sp>
       <p:sp>
         <p:nvSpPr>
-          <p:cNvPr id="8" name="TextBox 7"/>
-          <p:cNvSpPr txBox="1"/>
-          <p:nvPr/>
-        </p:nvSpPr>
-        <p:spPr>
-          <a:xfrm>
-            <a:off x="841248" y="4434840"/>
-            <a:ext cx="5852160" cy="1097280"/>
+          <p:cNvPr id="10" name="TextBox 9"/>
+          <p:cNvSpPr txBox="1"/>
+          <p:nvPr/>
+        </p:nvSpPr>
+        <p:spPr>
+          <a:xfrm>
+            <a:off x="841248" y="1920240"/>
+            <a:ext cx="4389120" cy="914400"/>
           </a:xfrm>
           <a:prstGeom prst="rect">
             <a:avLst/>
@@ -7618,14 +7650,14 @@
       </p:sp>
       <p:sp>
         <p:nvSpPr>
-          <p:cNvPr id="9" name="TextBox 8"/>
-          <p:cNvSpPr txBox="1"/>
-          <p:nvPr/>
-        </p:nvSpPr>
-        <p:spPr>
-          <a:xfrm>
-            <a:off x="841248" y="5212080"/>
-            <a:ext cx="5852160" cy="731520"/>
+          <p:cNvPr id="11" name="TextBox 10"/>
+          <p:cNvSpPr txBox="1"/>
+          <p:nvPr/>
+        </p:nvSpPr>
+        <p:spPr>
+          <a:xfrm>
+            <a:off x="841248" y="2743200"/>
+            <a:ext cx="4297680" cy="1280160"/>
           </a:xfrm>
           <a:prstGeom prst="rect">
             <a:avLst/>
@@ -7650,21 +7682,21 @@
                 </a:solidFill>
                 <a:latin typeface="Segoe UI Light"/>
               </a:rPr>
-              <a:t>A registered point cloud pulled patiently into an accurate as-built Revit model — the literal proof of what we do.</a:t>
-            </a:r>
-          </a:p>
-        </p:txBody>
-      </p:sp>
-      <p:sp>
-        <p:nvSpPr>
-          <p:cNvPr id="10" name="TextBox 9"/>
-          <p:cNvSpPr txBox="1"/>
-          <p:nvPr/>
-        </p:nvSpPr>
-        <p:spPr>
-          <a:xfrm>
-            <a:off x="841248" y="5989320"/>
-            <a:ext cx="2011680" cy="822960"/>
+              <a:t>The same corner, twice: a registered point cloud pulled patiently into an accurate as-built Revit model — the literal proof of what we do.</a:t>
+            </a:r>
+          </a:p>
+        </p:txBody>
+      </p:sp>
+      <p:sp>
+        <p:nvSpPr>
+          <p:cNvPr id="12" name="TextBox 11"/>
+          <p:cNvSpPr txBox="1"/>
+          <p:nvPr/>
+        </p:nvSpPr>
+        <p:spPr>
+          <a:xfrm>
+            <a:off x="841248" y="5120640"/>
+            <a:ext cx="1554480" cy="822960"/>
           </a:xfrm>
           <a:prstGeom prst="rect">
             <a:avLst/>
@@ -7683,7 +7715,7 @@
               </a:lnSpc>
             </a:pPr>
             <a:r>
-              <a:rPr sz="2400" b="0" i="0">
+              <a:rPr sz="2200" b="0" i="0">
                 <a:solidFill>
                   <a:srgbClr val="ECE3D1"/>
                 </a:solidFill>
@@ -7699,7 +7731,7 @@
               </a:lnSpc>
             </a:pPr>
             <a:r>
-              <a:rPr sz="850" b="0" i="0">
+              <a:rPr sz="800" b="0" i="0">
                 <a:solidFill>
                   <a:srgbClr val="877C6B"/>
                 </a:solidFill>
@@ -7712,14 +7744,14 @@
       </p:sp>
       <p:sp>
         <p:nvSpPr>
-          <p:cNvPr id="11" name="TextBox 10"/>
-          <p:cNvSpPr txBox="1"/>
-          <p:nvPr/>
-        </p:nvSpPr>
-        <p:spPr>
-          <a:xfrm>
-            <a:off x="2944368" y="5989320"/>
-            <a:ext cx="2011680" cy="822960"/>
+          <p:cNvPr id="13" name="TextBox 12"/>
+          <p:cNvSpPr txBox="1"/>
+          <p:nvPr/>
+        </p:nvSpPr>
+        <p:spPr>
+          <a:xfrm>
+            <a:off x="2414016" y="5120640"/>
+            <a:ext cx="1554480" cy="822960"/>
           </a:xfrm>
           <a:prstGeom prst="rect">
             <a:avLst/>
@@ -7738,7 +7770,7 @@
               </a:lnSpc>
             </a:pPr>
             <a:r>
-              <a:rPr sz="2400" b="0" i="0">
+              <a:rPr sz="2200" b="0" i="0">
                 <a:solidFill>
                   <a:srgbClr val="BD9457"/>
                 </a:solidFill>
@@ -7754,7 +7786,7 @@
               </a:lnSpc>
             </a:pPr>
             <a:r>
-              <a:rPr sz="850" b="0" i="0">
+              <a:rPr sz="800" b="0" i="0">
                 <a:solidFill>
                   <a:srgbClr val="877C6B"/>
                 </a:solidFill>
@@ -7767,14 +7799,14 @@
       </p:sp>
       <p:sp>
         <p:nvSpPr>
-          <p:cNvPr id="12" name="TextBox 11"/>
-          <p:cNvSpPr txBox="1"/>
-          <p:nvPr/>
-        </p:nvSpPr>
-        <p:spPr>
-          <a:xfrm>
-            <a:off x="5047488" y="5989320"/>
-            <a:ext cx="2011680" cy="822960"/>
+          <p:cNvPr id="14" name="TextBox 13"/>
+          <p:cNvSpPr txBox="1"/>
+          <p:nvPr/>
+        </p:nvSpPr>
+        <p:spPr>
+          <a:xfrm>
+            <a:off x="3986784" y="5120640"/>
+            <a:ext cx="1554480" cy="822960"/>
           </a:xfrm>
           <a:prstGeom prst="rect">
             <a:avLst/>
@@ -7793,7 +7825,7 @@
               </a:lnSpc>
             </a:pPr>
             <a:r>
-              <a:rPr sz="2400" b="0" i="0">
+              <a:rPr sz="2200" b="0" i="0">
                 <a:solidFill>
                   <a:srgbClr val="ECE3D1"/>
                 </a:solidFill>
@@ -7809,7 +7841,7 @@
               </a:lnSpc>
             </a:pPr>
             <a:r>
-              <a:rPr sz="850" b="0" i="0">
+              <a:rPr sz="800" b="0" i="0">
                 <a:solidFill>
                   <a:srgbClr val="877C6B"/>
                 </a:solidFill>
@@ -7940,12 +7972,20 @@
           </a:p>
         </p:txBody>
       </p:sp>
-      <p:sp>
-        <p:nvSpPr>
-          <p:cNvPr id="5" name="Rectangle 4"/>
-          <p:cNvSpPr/>
-          <p:nvPr/>
-        </p:nvSpPr>
+      <p:pic>
+        <p:nvPicPr>
+          <p:cNvPr id="5" name="Picture 4" descr="proj_leas.jpg"/>
+          <p:cNvPicPr>
+            <a:picLocks noChangeAspect="1"/>
+          </p:cNvPicPr>
+          <p:nvPr/>
+        </p:nvPicPr>
+        <p:blipFill>
+          <a:blip r:embed="rId3"/>
+          <a:stretch>
+            <a:fillRect/>
+          </a:stretch>
+        </p:blipFill>
         <p:spPr>
           <a:xfrm>
             <a:off x="6126480" y="1371600"/>
@@ -7954,47 +7994,13 @@
           <a:prstGeom prst="rect">
             <a:avLst/>
           </a:prstGeom>
-          <a:solidFill>
-            <a:srgbClr val="201912"/>
-          </a:solidFill>
           <a:ln w="12700">
             <a:solidFill>
-              <a:srgbClr val="BD9457"/>
+              <a:srgbClr val="2A2114"/>
             </a:solidFill>
           </a:ln>
         </p:spPr>
-        <p:style>
-          <a:lnRef idx="1">
-            <a:schemeClr val="accent1"/>
-          </a:lnRef>
-          <a:fillRef idx="3">
-            <a:schemeClr val="accent1"/>
-          </a:fillRef>
-          <a:effectRef idx="2">
-            <a:schemeClr val="accent1"/>
-          </a:effectRef>
-          <a:fontRef idx="minor">
-            <a:schemeClr val="lt1"/>
-          </a:fontRef>
-        </p:style>
-        <p:txBody>
-          <a:bodyPr rtlCol="0" anchor="ctr" wrap="square"/>
-          <a:lstStyle/>
-          <a:p>
-            <a:pPr algn="ctr"/>
-            <a:r>
-              <a:rPr sz="1100">
-                <a:solidFill>
-                  <a:srgbClr val="877C6B"/>
-                </a:solidFill>
-                <a:latin typeface="Consolas"/>
-              </a:rPr>
-              <a:t>PROJECT IMAGE
-→ push to  pptx/projects/leas/</a:t>
-            </a:r>
-          </a:p>
-        </p:txBody>
-      </p:sp>
+      </p:pic>
       <p:sp>
         <p:nvSpPr>
           <p:cNvPr id="6" name="TextBox 5"/>
@@ -8082,7 +8088,7 @@
         <p:spPr>
           <a:xfrm>
             <a:off x="841248" y="2606040"/>
-            <a:ext cx="5029200" cy="2194560"/>
+            <a:ext cx="5029200" cy="2377440"/>
           </a:xfrm>
           <a:prstGeom prst="rect">
             <a:avLst/>
@@ -8104,13 +8110,13 @@
               </a:spcAft>
             </a:pPr>
             <a:r>
-              <a:rPr sz="1350" b="0" i="0">
+              <a:rPr sz="1300" b="0" i="0">
                 <a:solidFill>
                   <a:srgbClr val="B9AE99"/>
                 </a:solidFill>
                 <a:latin typeface="Segoe UI Light"/>
               </a:rPr>
-              <a:t>Folkestone, Kent — a heritage commercial scheme in the United Kingdom.</a:t>
+              <a:t>Folkestone, Kent — restoration of a Grade II listed Edwardian tea room (1902), with a new nine-storey development of 91 sea-view apartments rising above it.</a:t>
             </a:r>
           </a:p>
           <a:p>
@@ -8120,13 +8126,13 @@
               </a:lnSpc>
             </a:pPr>
             <a:r>
-              <a:rPr sz="1250" b="0" i="0">
+              <a:rPr sz="1150" b="0" i="0">
                 <a:solidFill>
                   <a:srgbClr val="877C6B"/>
                 </a:solidFill>
                 <a:latin typeface="Segoe UI Light"/>
               </a:rPr>
-              <a:t>BIM delivery led by ECY's BIM Manager, Enes Cemil Yağcı, drawing on his professional experience on UK projects — part of the expertise ECY now brings to British clients.</a:t>
+              <a:t>RIBA Stage 5–7 execution drawings and structural, mechanical &amp; electrical coordination; BIM model and subcontractor drawing review for dimensional accuracy and tolerances — led by ECY's BIM Manager, Enes Cemil Yağcı. Part of the expertise ECY now brings to British clients.</a:t>
             </a:r>
           </a:p>
         </p:txBody>
@@ -8139,33 +8145,214 @@
         </p:nvSpPr>
         <p:spPr>
           <a:xfrm>
-            <a:off x="841248" y="5029200"/>
-            <a:ext cx="5029200" cy="365760"/>
-          </a:xfrm>
-          <a:prstGeom prst="rect">
-            <a:avLst/>
-          </a:prstGeom>
-          <a:noFill/>
-        </p:spPr>
-        <p:txBody>
-          <a:bodyPr wrap="square" anchor="t" lIns="0" rIns="0" tIns="0" bIns="0">
-            <a:spAutoFit/>
-          </a:bodyPr>
-          <a:lstStyle/>
-          <a:p>
-            <a:pPr algn="l">
-              <a:lnSpc>
-                <a:spcPct val="100000"/>
-              </a:lnSpc>
-            </a:pPr>
-            <a:r>
-              <a:rPr sz="850" b="0" i="0">
-                <a:solidFill>
-                  <a:srgbClr val="6E6657"/>
+            <a:off x="841248" y="5257800"/>
+            <a:ext cx="1371600" cy="822960"/>
+          </a:xfrm>
+          <a:prstGeom prst="rect">
+            <a:avLst/>
+          </a:prstGeom>
+          <a:noFill/>
+        </p:spPr>
+        <p:txBody>
+          <a:bodyPr wrap="square" anchor="t" lIns="0" rIns="0" tIns="0" bIns="0">
+            <a:spAutoFit/>
+          </a:bodyPr>
+          <a:lstStyle/>
+          <a:p>
+            <a:pPr algn="l">
+              <a:lnSpc>
+                <a:spcPct val="90000"/>
+              </a:lnSpc>
+            </a:pPr>
+            <a:r>
+              <a:rPr sz="2200" b="0" i="0">
+                <a:solidFill>
+                  <a:srgbClr val="BD9457"/>
+                </a:solidFill>
+                <a:latin typeface="Segoe UI Light"/>
+              </a:rPr>
+              <a:t>1902</a:t>
+            </a:r>
+          </a:p>
+          <a:p>
+            <a:pPr algn="l">
+              <a:lnSpc>
+                <a:spcPct val="100000"/>
+              </a:lnSpc>
+            </a:pPr>
+            <a:r>
+              <a:rPr sz="800" b="0" i="0">
+                <a:solidFill>
+                  <a:srgbClr val="877C6B"/>
                 </a:solidFill>
                 <a:latin typeface="Consolas"/>
               </a:rPr>
-              <a:t>{{replace caption with your künye text}}</a:t>
+              <a:t>GRADE II LISTED</a:t>
+            </a:r>
+          </a:p>
+        </p:txBody>
+      </p:sp>
+      <p:sp>
+        <p:nvSpPr>
+          <p:cNvPr id="10" name="TextBox 9"/>
+          <p:cNvSpPr txBox="1"/>
+          <p:nvPr/>
+        </p:nvSpPr>
+        <p:spPr>
+          <a:xfrm>
+            <a:off x="2139696" y="5257800"/>
+            <a:ext cx="1371600" cy="822960"/>
+          </a:xfrm>
+          <a:prstGeom prst="rect">
+            <a:avLst/>
+          </a:prstGeom>
+          <a:noFill/>
+        </p:spPr>
+        <p:txBody>
+          <a:bodyPr wrap="square" anchor="t" lIns="0" rIns="0" tIns="0" bIns="0">
+            <a:spAutoFit/>
+          </a:bodyPr>
+          <a:lstStyle/>
+          <a:p>
+            <a:pPr algn="l">
+              <a:lnSpc>
+                <a:spcPct val="90000"/>
+              </a:lnSpc>
+            </a:pPr>
+            <a:r>
+              <a:rPr sz="2200" b="0" i="0">
+                <a:solidFill>
+                  <a:srgbClr val="ECE3D1"/>
+                </a:solidFill>
+                <a:latin typeface="Segoe UI Light"/>
+              </a:rPr>
+              <a:t>91</a:t>
+            </a:r>
+          </a:p>
+          <a:p>
+            <a:pPr algn="l">
+              <a:lnSpc>
+                <a:spcPct val="100000"/>
+              </a:lnSpc>
+            </a:pPr>
+            <a:r>
+              <a:rPr sz="800" b="0" i="0">
+                <a:solidFill>
+                  <a:srgbClr val="877C6B"/>
+                </a:solidFill>
+                <a:latin typeface="Consolas"/>
+              </a:rPr>
+              <a:t>APARTMENTS</a:t>
+            </a:r>
+          </a:p>
+        </p:txBody>
+      </p:sp>
+      <p:sp>
+        <p:nvSpPr>
+          <p:cNvPr id="11" name="TextBox 10"/>
+          <p:cNvSpPr txBox="1"/>
+          <p:nvPr/>
+        </p:nvSpPr>
+        <p:spPr>
+          <a:xfrm>
+            <a:off x="3438144" y="5257800"/>
+            <a:ext cx="1371600" cy="822960"/>
+          </a:xfrm>
+          <a:prstGeom prst="rect">
+            <a:avLst/>
+          </a:prstGeom>
+          <a:noFill/>
+        </p:spPr>
+        <p:txBody>
+          <a:bodyPr wrap="square" anchor="t" lIns="0" rIns="0" tIns="0" bIns="0">
+            <a:spAutoFit/>
+          </a:bodyPr>
+          <a:lstStyle/>
+          <a:p>
+            <a:pPr algn="l">
+              <a:lnSpc>
+                <a:spcPct val="90000"/>
+              </a:lnSpc>
+            </a:pPr>
+            <a:r>
+              <a:rPr sz="2200" b="0" i="0">
+                <a:solidFill>
+                  <a:srgbClr val="ECE3D1"/>
+                </a:solidFill>
+                <a:latin typeface="Segoe UI Light"/>
+              </a:rPr>
+              <a:t>5–7</a:t>
+            </a:r>
+          </a:p>
+          <a:p>
+            <a:pPr algn="l">
+              <a:lnSpc>
+                <a:spcPct val="100000"/>
+              </a:lnSpc>
+            </a:pPr>
+            <a:r>
+              <a:rPr sz="800" b="0" i="0">
+                <a:solidFill>
+                  <a:srgbClr val="877C6B"/>
+                </a:solidFill>
+                <a:latin typeface="Consolas"/>
+              </a:rPr>
+              <a:t>RIBA STAGES</a:t>
+            </a:r>
+          </a:p>
+        </p:txBody>
+      </p:sp>
+      <p:sp>
+        <p:nvSpPr>
+          <p:cNvPr id="12" name="TextBox 11"/>
+          <p:cNvSpPr txBox="1"/>
+          <p:nvPr/>
+        </p:nvSpPr>
+        <p:spPr>
+          <a:xfrm>
+            <a:off x="4736592" y="5257800"/>
+            <a:ext cx="1371600" cy="822960"/>
+          </a:xfrm>
+          <a:prstGeom prst="rect">
+            <a:avLst/>
+          </a:prstGeom>
+          <a:noFill/>
+        </p:spPr>
+        <p:txBody>
+          <a:bodyPr wrap="square" anchor="t" lIns="0" rIns="0" tIns="0" bIns="0">
+            <a:spAutoFit/>
+          </a:bodyPr>
+          <a:lstStyle/>
+          <a:p>
+            <a:pPr algn="l">
+              <a:lnSpc>
+                <a:spcPct val="90000"/>
+              </a:lnSpc>
+            </a:pPr>
+            <a:r>
+              <a:rPr sz="2200" b="0" i="0">
+                <a:solidFill>
+                  <a:srgbClr val="ECE3D1"/>
+                </a:solidFill>
+                <a:latin typeface="Segoe UI Light"/>
+              </a:rPr>
+              <a:t>133,715</a:t>
+            </a:r>
+          </a:p>
+          <a:p>
+            <a:pPr algn="l">
+              <a:lnSpc>
+                <a:spcPct val="100000"/>
+              </a:lnSpc>
+            </a:pPr>
+            <a:r>
+              <a:rPr sz="800" b="0" i="0">
+                <a:solidFill>
+                  <a:srgbClr val="877C6B"/>
+                </a:solidFill>
+                <a:latin typeface="Consolas"/>
+              </a:rPr>
+              <a:t>SQ FT</a:t>
             </a:r>
           </a:p>
         </p:txBody>

</xml_diff>